<commit_message>
Update Alliance_Garbage_Management_Presentation.pptx with user credentials
</commit_message>
<xml_diff>
--- a/Alliance_Garbage_Management_Presentation.pptx
+++ b/Alliance_Garbage_Management_Presentation.pptx
@@ -6421,7 +6421,7 @@
                 <a:cs typeface="Times New Roman" panose="02020603050405020304"/>
                 <a:sym typeface="Times New Roman" panose="02020603050405020304"/>
               </a:rPr>
-              <a:t>Student Name: Thukivakam Chaturya Reddy</a:t>
+              <a:t>Student Name: Thukivakam Chaturya</a:t>
             </a:r>
             <a:endParaRPr sz="2000">
               <a:latin typeface="Times New Roman" panose="02020603050405020304"/>
@@ -6450,7 +6450,7 @@
                 <a:cs typeface="Times New Roman" panose="02020603050405020304"/>
                 <a:sym typeface="Times New Roman" panose="02020603050405020304"/>
               </a:rPr>
-              <a:t>RegisterNumber: [Enter Register Number]</a:t>
+              <a:t>RegisterNumber: 2411021240045</a:t>
             </a:r>
             <a:endParaRPr sz="2000">
               <a:latin typeface="Times New Roman" panose="02020603050405020304"/>
@@ -6479,7 +6479,7 @@
                 <a:cs typeface="Times New Roman" panose="02020603050405020304"/>
                 <a:sym typeface="Times New Roman" panose="02020603050405020304"/>
               </a:rPr>
-              <a:t>Specialization: BCA, Final Year</a:t>
+              <a:t>Specialization: BCA (AI/ML), Final Year</a:t>
             </a:r>
             <a:endParaRPr sz="2000">
               <a:latin typeface="Times New Roman" panose="02020603050405020304"/>
@@ -6896,12 +6896,38 @@
               </a:rPr>
               <a:t>Thank You</a:t>
             </a:r>
-            <a:endParaRPr sz="7300">
-              <a:latin typeface="Times New Roman" panose="02020603050405020304"/>
-              <a:ea typeface="Times New Roman" panose="02020603050405020304"/>
-              <a:cs typeface="Times New Roman" panose="02020603050405020304"/>
-              <a:sym typeface="Times New Roman" panose="02020603050405020304"/>
-            </a:endParaRPr>
+          </a:p>
+          <a:p>
+            <a:pPr marL="12700" lvl="0" indent="0" algn="l" rtl="0">
+              <a:spcBef>
+                <a:spcPts val="1200"/>
+              </a:spcBef>
+            </a:pPr>
+            <a:r>
+              <a:rPr lang="en-US" sz="2200" b="1">
+                <a:solidFill>
+                  <a:srgbClr val="A31D24"/>
+                </a:solidFill>
+                <a:latin typeface="Times New Roman"/>
+              </a:rPr>
+              <a:t>Thukivakam Chaturya | Reg: 2411021240045 | BCA (AI/ML)</a:t>
+            </a:r>
+          </a:p>
+          <a:p>
+            <a:pPr marL="12700" lvl="0" indent="0" algn="l" rtl="0">
+              <a:spcBef>
+                <a:spcPts val="600"/>
+              </a:spcBef>
+            </a:pPr>
+            <a:r>
+              <a:rPr lang="en-US" sz="1600">
+                <a:solidFill>
+                  <a:srgbClr val="4B5563"/>
+                </a:solidFill>
+                <a:latin typeface="Times New Roman"/>
+              </a:rPr>
+              <a:t>GitHub: https://github.com/Chaturyathukivakam/Garbage-System</a:t>
+            </a:r>
           </a:p>
         </p:txBody>
       </p:sp>

</xml_diff>